<commit_message>
Focus presentation conclusion on measured achievements
</commit_message>
<xml_diff>
--- a/performance-testing/documentation/KS_Tema14_Prezentacia_Mykhailo_Adamenko.pptx
+++ b/performance-testing/documentation/KS_Tema14_Prezentacia_Mykhailo_Adamenko.pptx
@@ -665,13 +665,13 @@
           <a:lstStyle/>
           <a:p>
             <a:r>
-              <a:t>Odporúčaný čas: 70 s.</a:t>
+              <a:t>Odporúčaný čas: 55 s.</a:t>
             </a:r>
           </a:p>
           <a:p/>
           <a:p>
             <a:r>
-              <a:t>PR-01 aj PR-02 zostali nesplnené: pri 20 súčasných používateľoch bola hranica 9,102 s namiesto menej než 0,8 s a pri 50 používateľoch 24,321 s namiesto menej než 1,5 s. Po úprave bežná záťaž splnila spoľahlivosť a výstupy boli správne. Pri stresovom teste chyby klesli z 58,93 % na 21,36 %, ale prerušené iterácie vzrástli z 29 na 59. Krátky trojminútový test splnil vopred definované kritérium stability; dlhodobú prevádzku tým nepotvrdzujeme. Kontrolné používateľské toky prešli 40 zo 40 kontrol. Limity: jeden lokálny worker, spoločná učiteľská session, krátke behy a jedno HTTP meranie každej konfigurácie.</a:t>
+              <a:t>Na tomto slajde zhrniem dosiahnuté výsledky. Pri kurze s 1000 študentmi a 20 súčasných používateľoch sa sledovaný čas odozvy skrátil približne o 56 %. Ide o hranicu pre 95 zo 100 dokončených odpovedí, vysvetlenú na predchádzajúcom slajde. Celé výstupy prehľadu boli zhodné pred úpravou aj po nej vo všetkých troch veľkostiach kurzu. Prešlo 51 automatizovaných testov s 244 kontrolami. V nameraných behoch bežnej záťaže po úprave neboli zaznamenané chyby ani prerušené iterácie. Tieto výsledky sa vzťahujú na vykonané lokálne merania.</a:t>
             </a:r>
           </a:p>
         </p:txBody>
@@ -747,7 +747,7 @@
           <a:p/>
           <a:p>
             <a:r>
-              <a:t>Prínosom výkonnostného testovania je konkrétny podklad pre rozhodnutie, čo zmeniť, a možnosť overiť výsledok. Automatizovaný nástroj umožnil opakovať rovnaké scenáre, ale lokálne prostredie obmedzuje prenos výsledkov do produkcie. Ďalší krok je produkčne podobný server, viac opakovaní a plný dlhodobý test. Reprodukčné príkazy, surové merania, úpravy kódu a testy sú súčasťou odovzdania.</a:t>
+              <a:t>Hlavným prínosom projektu je prepojenie merania s konkrétnou úpravou aplikácie. Najprv sme identifikovali opakované spracovanie údajov, potom ho obmedzili a rovnakými testami overili účinok. Výsledkom je namerané zrýchlenie pri zachovaní správnosti prehľadu. Aplikácia z bakalárskej práce tak poslúžila ako praktický príklad využitia výkonnostného testovania. Ďakujem za pozornosť.</a:t>
             </a:r>
           </a:p>
           <a:p/>
@@ -5804,7 +5804,7 @@
               </a:defRPr>
             </a:pPr>
             <a:r>
-              <a:t>10 / SPLNILI SME CIEĽ?</a:t>
+              <a:t>10 / DOSIAHNUTÉ VÝSLEDKY</a:t>
             </a:r>
           </a:p>
         </p:txBody>
@@ -5843,7 +5843,7 @@
               </a:defRPr>
             </a:pPr>
             <a:r>
-              <a:t>Zlepšenie áno. Všetky požiadavky ešte nie.</a:t>
+              <a:t>Rýchlejšie spracovanie. Zachovaná správnosť.</a:t>
             </a:r>
           </a:p>
         </p:txBody>
@@ -6085,7 +6085,7 @@
               </a:defRPr>
             </a:pPr>
             <a:r>
-              <a:t>Správnosť výsledkov</a:t>
+              <a:t>Sledovaný čas odozvy</a:t>
             </a:r>
           </a:p>
         </p:txBody>
@@ -6124,7 +6124,7 @@
               </a:defRPr>
             </a:pPr>
             <a:r>
-              <a:t>Zachovaná</a:t>
+              <a:t>Skrátený o 56 %</a:t>
             </a:r>
           </a:p>
         </p:txBody>
@@ -6253,7 +6253,7 @@
               </a:defRPr>
             </a:pPr>
             <a:r>
-              <a:t>Bežná záťaž po úprave</a:t>
+              <a:t>Výsledky prehľadu</a:t>
             </a:r>
           </a:p>
         </p:txBody>
@@ -6292,7 +6292,7 @@
               </a:defRPr>
             </a:pPr>
             <a:r>
-              <a:t>Bez chýb a prerušených behov</a:t>
+              <a:t>Zhodné vo všetkých 3 kurzoch</a:t>
             </a:r>
           </a:p>
         </p:txBody>
@@ -6359,7 +6359,7 @@
             <a:avLst/>
           </a:prstGeom>
           <a:solidFill>
-            <a:srgbClr val="CA5C69"/>
+            <a:srgbClr val="19B7A4"/>
           </a:solidFill>
           <a:ln>
             <a:noFill/>
@@ -6421,7 +6421,7 @@
               </a:defRPr>
             </a:pPr>
             <a:r>
-              <a:t>Požadovaná rýchlosť</a:t>
+              <a:t>Automatizované testy</a:t>
             </a:r>
           </a:p>
         </p:txBody>
@@ -6454,13 +6454,13 @@
               </a:spcAft>
               <a:defRPr sz="2000" b="1">
                 <a:solidFill>
-                  <a:srgbClr val="CA5C69"/>
-                </a:solidFill>
-                <a:latin typeface="Aptos"/>
-              </a:defRPr>
-            </a:pPr>
-            <a:r>
-              <a:t>Zatiaľ nesplnená</a:t>
+                  <a:srgbClr val="078476"/>
+                </a:solidFill>
+                <a:latin typeface="Aptos"/>
+              </a:defRPr>
+            </a:pPr>
+            <a:r>
+              <a:t>51 úspešných testov</a:t>
             </a:r>
           </a:p>
         </p:txBody>
@@ -6527,7 +6527,7 @@
             <a:avLst/>
           </a:prstGeom>
           <a:solidFill>
-            <a:srgbClr val="CA5C69"/>
+            <a:srgbClr val="19B7A4"/>
           </a:solidFill>
           <a:ln>
             <a:noFill/>
@@ -6589,7 +6589,7 @@
               </a:defRPr>
             </a:pPr>
             <a:r>
-              <a:t>Vysoká záťaž</a:t>
+              <a:t>Bežná záťaž po úprave</a:t>
             </a:r>
           </a:p>
         </p:txBody>
@@ -6622,13 +6622,13 @@
               </a:spcAft>
               <a:defRPr sz="2000" b="1">
                 <a:solidFill>
-                  <a:srgbClr val="CA5C69"/>
-                </a:solidFill>
-                <a:latin typeface="Aptos"/>
-              </a:defRPr>
-            </a:pPr>
-            <a:r>
-              <a:t>Stále spôsobuje chyby</a:t>
+                  <a:srgbClr val="078476"/>
+                </a:solidFill>
+                <a:latin typeface="Aptos"/>
+              </a:defRPr>
+            </a:pPr>
+            <a:r>
+              <a:t>Bez chýb a prerušených behov</a:t>
             </a:r>
           </a:p>
         </p:txBody>
@@ -6659,7 +6659,7 @@
               <a:spcAft>
                 <a:spcPts val="500"/>
               </a:spcAft>
-              <a:defRPr sz="2100" b="0">
+              <a:defRPr sz="2000" b="0">
                 <a:solidFill>
                   <a:srgbClr val="627387"/>
                 </a:solidFill>
@@ -6667,7 +6667,7 @@
               </a:defRPr>
             </a:pPr>
             <a:r>
-              <a:t>Stabilitu sme overili iba krátko: tri minúty na lokálnom počítači.</a:t>
+              <a:t>Záťažové porovnanie: lokálny server · 20 súčasných používateľov.</a:t>
             </a:r>
           </a:p>
         </p:txBody>
@@ -6814,7 +6814,7 @@
               </a:defRPr>
             </a:pPr>
             <a:r>
-              <a:t>Testovanie ukázalo problém aj prínos úpravy.</a:t>
+              <a:t>Od merania ku konkrétnemu zlepšeniu.</a:t>
             </a:r>
           </a:p>
         </p:txBody>
@@ -7011,7 +7011,7 @@
               </a:defRPr>
             </a:pPr>
             <a:r>
-              <a:t>Zmerať</a:t>
+              <a:t>Zistenie</a:t>
             </a:r>
           </a:p>
         </p:txBody>
@@ -7050,7 +7050,7 @@
               </a:defRPr>
             </a:pPr>
             <a:r>
-              <a:t>Zistiť, kde a kedy</a:t>
+              <a:t>Našli sme zbytočne</a:t>
             </a:r>
           </a:p>
           <a:p>
@@ -7066,7 +7066,7 @@
               </a:defRPr>
             </a:pPr>
             <a:r>
-              <a:t>sa aplikácia spomaľuje.</a:t>
+              <a:t>opakované spracovanie.</a:t>
             </a:r>
           </a:p>
         </p:txBody>
@@ -7150,7 +7150,7 @@
               </a:defRPr>
             </a:pPr>
             <a:r>
-              <a:t>Upraviť</a:t>
+              <a:t>Úprava</a:t>
             </a:r>
           </a:p>
         </p:txBody>
@@ -7189,7 +7189,7 @@
               </a:defRPr>
             </a:pPr>
             <a:r>
-              <a:t>Odstrániť príčinu</a:t>
+              <a:t>Znížili sme množstvo</a:t>
             </a:r>
           </a:p>
           <a:p>
@@ -7205,7 +7205,7 @@
               </a:defRPr>
             </a:pPr>
             <a:r>
-              <a:t>a zachovať správnosť.</a:t>
+              <a:t>opakovanej práce.</a:t>
             </a:r>
           </a:p>
         </p:txBody>
@@ -7289,7 +7289,7 @@
               </a:defRPr>
             </a:pPr>
             <a:r>
-              <a:t>Overiť</a:t>
+              <a:t>Overenie</a:t>
             </a:r>
           </a:p>
         </p:txBody>
@@ -7328,7 +7328,7 @@
               </a:defRPr>
             </a:pPr>
             <a:r>
-              <a:t>Znovu merať</a:t>
+              <a:t>Potvrdili sme zrýchlenie</a:t>
             </a:r>
           </a:p>
           <a:p>
@@ -7344,7 +7344,7 @@
               </a:defRPr>
             </a:pPr>
             <a:r>
-              <a:t>a priznať zostávajúce limity.</a:t>
+              <a:t>a zhodnosť výsledkov.</a:t>
             </a:r>
           </a:p>
         </p:txBody>
@@ -7383,7 +7383,7 @@
               </a:defRPr>
             </a:pPr>
             <a:r>
-              <a:t>Ďalší krok: dlhšie a opakované testy na serveri podobnom reálnej prevádzke.</a:t>
+              <a:t>Meranie pomohlo vybrať účinnú úpravu a overiť jej výsledok.</a:t>
             </a:r>
           </a:p>
         </p:txBody>

</xml_diff>